<commit_message>
Address tutorial setup and DGAT evaluation feedback
</commit_message>
<xml_diff>
--- a/outputs/eccb_2026_dgat_tutorial_slides.pptx
+++ b/outputs/eccb_2026_dgat_tutorial_slides.pptx
@@ -2,24 +2,24 @@
 <file path=ppt/presentation.xml><?xml version="1.0" encoding="utf-8"?>
 <p:presentation xmlns:p="http://schemas.openxmlformats.org/presentationml/2006/main">
   <p:sldMasterIdLst>
-    <p:sldMasterId xmlns:r="http://schemas.openxmlformats.org/officeDocument/2006/relationships" id="2147483648" r:id="Rf9ea6c3c22aa400c"/>
+    <p:sldMasterId xmlns:r="http://schemas.openxmlformats.org/officeDocument/2006/relationships" id="2147483648" r:id="R820dd199f9024387"/>
   </p:sldMasterIdLst>
   <p:notesMasterIdLst>
-    <p:notesMasterId xmlns:r="http://schemas.openxmlformats.org/officeDocument/2006/relationships" r:id="Rf1c4a23d9f934f47"/>
+    <p:notesMasterId xmlns:r="http://schemas.openxmlformats.org/officeDocument/2006/relationships" r:id="Rd40205875d204d21"/>
   </p:notesMasterIdLst>
   <p:sldIdLst>
-    <p:sldId xmlns:r="http://schemas.openxmlformats.org/officeDocument/2006/relationships" id="256" r:id="R52ea283e17d64104"/>
-    <p:sldId xmlns:r="http://schemas.openxmlformats.org/officeDocument/2006/relationships" id="257" r:id="R9c5a731752174508"/>
-    <p:sldId xmlns:r="http://schemas.openxmlformats.org/officeDocument/2006/relationships" id="258" r:id="R84cb24fb29fa40ad"/>
-    <p:sldId xmlns:r="http://schemas.openxmlformats.org/officeDocument/2006/relationships" id="259" r:id="R1d8caa30f8514c69"/>
-    <p:sldId xmlns:r="http://schemas.openxmlformats.org/officeDocument/2006/relationships" id="260" r:id="R0f2e1a31d5f84a61"/>
-    <p:sldId xmlns:r="http://schemas.openxmlformats.org/officeDocument/2006/relationships" id="261" r:id="R11fae752486740f4"/>
-    <p:sldId xmlns:r="http://schemas.openxmlformats.org/officeDocument/2006/relationships" id="262" r:id="R8ed0d447e520437b"/>
-    <p:sldId xmlns:r="http://schemas.openxmlformats.org/officeDocument/2006/relationships" id="263" r:id="Rd68581c212e342a2"/>
-    <p:sldId xmlns:r="http://schemas.openxmlformats.org/officeDocument/2006/relationships" id="264" r:id="Rb4ed7fcd7e224e67"/>
-    <p:sldId xmlns:r="http://schemas.openxmlformats.org/officeDocument/2006/relationships" id="265" r:id="R26cd0508afff4bd1"/>
-    <p:sldId xmlns:r="http://schemas.openxmlformats.org/officeDocument/2006/relationships" id="266" r:id="R6632cac35a904d9e"/>
-    <p:sldId xmlns:r="http://schemas.openxmlformats.org/officeDocument/2006/relationships" id="267" r:id="Rf5e52e0055264d92"/>
+    <p:sldId xmlns:r="http://schemas.openxmlformats.org/officeDocument/2006/relationships" id="256" r:id="Rde899261d2fd4e54"/>
+    <p:sldId xmlns:r="http://schemas.openxmlformats.org/officeDocument/2006/relationships" id="257" r:id="R3bf0230011dc4794"/>
+    <p:sldId xmlns:r="http://schemas.openxmlformats.org/officeDocument/2006/relationships" id="258" r:id="Re0229bfa31ab41b6"/>
+    <p:sldId xmlns:r="http://schemas.openxmlformats.org/officeDocument/2006/relationships" id="259" r:id="Ra7d5c31c944b41ec"/>
+    <p:sldId xmlns:r="http://schemas.openxmlformats.org/officeDocument/2006/relationships" id="260" r:id="R7b4de4c226364af7"/>
+    <p:sldId xmlns:r="http://schemas.openxmlformats.org/officeDocument/2006/relationships" id="261" r:id="R46434d6ee6604d3d"/>
+    <p:sldId xmlns:r="http://schemas.openxmlformats.org/officeDocument/2006/relationships" id="262" r:id="R190465e06b38453c"/>
+    <p:sldId xmlns:r="http://schemas.openxmlformats.org/officeDocument/2006/relationships" id="263" r:id="R480ccc1d4b0e4b0a"/>
+    <p:sldId xmlns:r="http://schemas.openxmlformats.org/officeDocument/2006/relationships" id="264" r:id="R3ff4833dfbf74247"/>
+    <p:sldId xmlns:r="http://schemas.openxmlformats.org/officeDocument/2006/relationships" id="265" r:id="Rf3c52425171f42b2"/>
+    <p:sldId xmlns:r="http://schemas.openxmlformats.org/officeDocument/2006/relationships" id="266" r:id="Ra62a7a6514364dde"/>
+    <p:sldId xmlns:r="http://schemas.openxmlformats.org/officeDocument/2006/relationships" id="267" r:id="R42a6f0b5b3ac444b"/>
   </p:sldIdLst>
   <p:sldSz cx="12192000" cy="6858000"/>
   <p:notesSz cx="6858000" cy="9144000"/>
@@ -1338,7 +1338,7 @@
   </p:cSld>
   <p:clrMap bg1="lt1" tx1="dk1" bg2="lt2" tx2="dk2" accent1="accent1" accent2="accent2" accent3="accent3" accent4="accent4" accent5="accent5" accent6="accent6" hlink="hlink" folHlink="folHlink"/>
   <p:sldLayoutIdLst>
-    <p:sldLayoutId xmlns:r="http://schemas.openxmlformats.org/officeDocument/2006/relationships" id="2147483649" r:id="R99045ef65afb407e"/>
+    <p:sldLayoutId xmlns:r="http://schemas.openxmlformats.org/officeDocument/2006/relationships" id="2147483649" r:id="Re829bc60da9a4f7e"/>
   </p:sldLayoutIdLst>
   <p:txStyles>
     <p:titleStyle>
@@ -1871,7 +1871,6 @@
   <c:roundedCorners val="0"/>
   <c:chart>
     <c:plotArea>
-      <c:layout/>
       <c:barChart>
         <c:barDir val="col"/>
         <c:varyColors val="0"/>
@@ -2065,7 +2064,7 @@
       </p:grpSpPr>
       <p:sp>
         <p:nvSpPr>
-          <p:cNvPr id="1" name="text">
+          <p:cNvPr id="18" name="text">
             <a:extLst xmlns:a="http://schemas.openxmlformats.org/drawingml/2006/main">
               <a:ext uri="{FF2B5EF4-FFF2-40B4-BE49-F238E27FC236}">
                 <a16:creationId xmlns:a16="http://schemas.microsoft.com/office/drawing/2014/main" id="{54B42DE0-4730-4848-894F-A2FE28F36CEC}"/>
@@ -2096,6 +2095,7 @@
           <a:lstStyle xmlns:a="http://schemas.openxmlformats.org/drawingml/2006/main"/>
           <a:p xmlns:a="http://schemas.openxmlformats.org/drawingml/2006/main">
             <a:pPr algn="l">
+              <a:buNone/>
               <a:defRPr sz="2400" b="0">
                 <a:solidFill>
                   <a:srgbClr val="000000"/>
@@ -2146,6 +2146,7 @@
           <a:lstStyle xmlns:a="http://schemas.openxmlformats.org/drawingml/2006/main"/>
           <a:p xmlns:a="http://schemas.openxmlformats.org/drawingml/2006/main">
             <a:pPr algn="l">
+              <a:buNone/>
               <a:defRPr sz="2400" b="0">
                 <a:solidFill>
                   <a:srgbClr val="555555"/>
@@ -2196,6 +2197,7 @@
           <a:lstStyle xmlns:a="http://schemas.openxmlformats.org/drawingml/2006/main"/>
           <a:p xmlns:a="http://schemas.openxmlformats.org/drawingml/2006/main">
             <a:pPr algn="r">
+              <a:buNone/>
               <a:defRPr sz="2400" b="0">
                 <a:solidFill>
                   <a:srgbClr val="000000"/>
@@ -2246,6 +2248,7 @@
           <a:lstStyle xmlns:a="http://schemas.openxmlformats.org/drawingml/2006/main"/>
           <a:p xmlns:a="http://schemas.openxmlformats.org/drawingml/2006/main">
             <a:pPr algn="l">
+              <a:buNone/>
               <a:defRPr sz="5400" b="0">
                 <a:solidFill>
                   <a:srgbClr val="000000"/>
@@ -2263,6 +2266,7 @@
           </a:p>
           <a:p xmlns:a="http://schemas.openxmlformats.org/drawingml/2006/main">
             <a:pPr algn="l">
+              <a:buNone/>
               <a:defRPr sz="5400" b="0">
                 <a:solidFill>
                   <a:srgbClr val="000000"/>
@@ -2313,6 +2317,7 @@
           <a:lstStyle xmlns:a="http://schemas.openxmlformats.org/drawingml/2006/main"/>
           <a:p xmlns:a="http://schemas.openxmlformats.org/drawingml/2006/main">
             <a:pPr algn="l">
+              <a:buNone/>
               <a:defRPr sz="2250" b="0">
                 <a:solidFill>
                   <a:srgbClr val="000000"/>
@@ -2394,6 +2399,7 @@
           <a:lstStyle xmlns:a="http://schemas.openxmlformats.org/drawingml/2006/main"/>
           <a:p xmlns:a="http://schemas.openxmlformats.org/drawingml/2006/main">
             <a:pPr algn="ctr">
+              <a:buNone/>
               <a:defRPr sz="4350" b="1">
                 <a:solidFill>
                   <a:srgbClr val="000000"/>
@@ -2413,7 +2419,7 @@
       </p:sp>
       <p:cxnSp>
         <p:nvCxnSpPr>
-          <p:cNvPr id="17" name="rule"/>
+          <p:cNvPr id="33" name="rule"/>
           <p:cNvCxnSpPr/>
           <p:nvPr/>
         </p:nvCxnSpPr>
@@ -2466,6 +2472,7 @@
           <a:lstStyle xmlns:a="http://schemas.openxmlformats.org/drawingml/2006/main"/>
           <a:p xmlns:a="http://schemas.openxmlformats.org/drawingml/2006/main">
             <a:pPr algn="l">
+              <a:buNone/>
               <a:defRPr sz="1800" b="0">
                 <a:solidFill>
                   <a:srgbClr val="555555"/>
@@ -2514,7 +2521,7 @@
       </p:grpSpPr>
       <p:sp>
         <p:nvSpPr>
-          <p:cNvPr id="1" name="text">
+          <p:cNvPr id="22" name="text">
             <a:extLst xmlns:a="http://schemas.openxmlformats.org/drawingml/2006/main">
               <a:ext uri="{FF2B5EF4-FFF2-40B4-BE49-F238E27FC236}">
                 <a16:creationId xmlns:a16="http://schemas.microsoft.com/office/drawing/2014/main" id="{FC31F9F1-B566-4822-B6AA-AD883BCE42F2}"/>
@@ -2545,6 +2552,7 @@
           <a:lstStyle xmlns:a="http://schemas.openxmlformats.org/drawingml/2006/main"/>
           <a:p xmlns:a="http://schemas.openxmlformats.org/drawingml/2006/main">
             <a:pPr algn="l">
+              <a:buNone/>
               <a:defRPr sz="1200" b="1">
                 <a:solidFill>
                   <a:srgbClr val="555555"/>
@@ -2595,6 +2603,7 @@
           <a:lstStyle xmlns:a="http://schemas.openxmlformats.org/drawingml/2006/main"/>
           <a:p xmlns:a="http://schemas.openxmlformats.org/drawingml/2006/main">
             <a:pPr algn="l">
+              <a:buNone/>
               <a:defRPr sz="3150" b="0">
                 <a:solidFill>
                   <a:srgbClr val="000000"/>
@@ -2607,7 +2616,7 @@
                   <a:srgbClr val="000000"/>
                 </a:solidFill>
               </a:rPr>
-              <a:t>Make the live session resilient</a:t>
+              <a:t>Make the live session independent of Wi-Fi</a:t>
             </a:r>
           </a:p>
         </p:txBody>
@@ -2645,6 +2654,7 @@
           <a:lstStyle xmlns:a="http://schemas.openxmlformats.org/drawingml/2006/main"/>
           <a:p xmlns:a="http://schemas.openxmlformats.org/drawingml/2006/main">
             <a:pPr algn="r">
+              <a:buNone/>
               <a:defRPr sz="1200" b="0">
                 <a:solidFill>
                   <a:srgbClr val="555555"/>
@@ -2695,6 +2705,7 @@
           <a:lstStyle xmlns:a="http://schemas.openxmlformats.org/drawingml/2006/main"/>
           <a:p xmlns:a="http://schemas.openxmlformats.org/drawingml/2006/main">
             <a:pPr algn="l">
+              <a:buNone/>
               <a:defRPr sz="2250" b="1">
                 <a:solidFill>
                   <a:srgbClr val="000000"/>
@@ -2707,7 +2718,7 @@
                   <a:srgbClr val="000000"/>
                 </a:solidFill>
               </a:rPr>
-              <a:t>Primary path</a:t>
+              <a:t>Participant path</a:t>
             </a:r>
           </a:p>
         </p:txBody>
@@ -2745,6 +2756,7 @@
           <a:lstStyle xmlns:a="http://schemas.openxmlformats.org/drawingml/2006/main"/>
           <a:p xmlns:a="http://schemas.openxmlformats.org/drawingml/2006/main">
             <a:pPr algn="l">
+              <a:buNone/>
               <a:defRPr sz="1800" b="0">
                 <a:solidFill>
                   <a:srgbClr val="000000"/>
@@ -2757,11 +2769,20 @@
                   <a:srgbClr val="000000"/>
                 </a:solidFill>
               </a:rPr>
-              <a:t>• DGAT assets already downloaded</a:t>
-            </a:r>
-          </a:p>
-          <a:p xmlns:a="http://schemas.openxmlformats.org/drawingml/2006/main">
-            <a:pPr algn="l">
+              <a:t>• </a:t>
+            </a:r>
+            <a:r>
+              <a:rPr sz="1800" b="0">
+                <a:solidFill>
+                  <a:srgbClr val="000000"/>
+                </a:solidFill>
+              </a:rPr>
+              <a:t>Data downloaded ≥24 h early</a:t>
+            </a:r>
+          </a:p>
+          <a:p xmlns:a="http://schemas.openxmlformats.org/drawingml/2006/main">
+            <a:pPr algn="l">
+              <a:buNone/>
               <a:defRPr sz="1800" b="0">
                 <a:solidFill>
                   <a:srgbClr val="000000"/>
@@ -2774,11 +2795,20 @@
                   <a:srgbClr val="000000"/>
                 </a:solidFill>
               </a:rPr>
-              <a:t>• CSV data prepared before class</a:t>
-            </a:r>
-          </a:p>
-          <a:p xmlns:a="http://schemas.openxmlformats.org/drawingml/2006/main">
-            <a:pPr algn="l">
+              <a:t>• </a:t>
+            </a:r>
+            <a:r>
+              <a:rPr sz="1800" b="0">
+                <a:solidFill>
+                  <a:srgbClr val="000000"/>
+                </a:solidFill>
+              </a:rPr>
+              <a:t>Precomputed DGAT predictions present</a:t>
+            </a:r>
+          </a:p>
+          <a:p xmlns:a="http://schemas.openxmlformats.org/drawingml/2006/main">
+            <a:pPr algn="l">
+              <a:buNone/>
               <a:defRPr sz="1800" b="0">
                 <a:solidFill>
                   <a:srgbClr val="000000"/>
@@ -2791,7 +2821,15 @@
                   <a:srgbClr val="000000"/>
                 </a:solidFill>
               </a:rPr>
-              <a:t>• One short live inference demonstration</a:t>
+              <a:t>• </a:t>
+            </a:r>
+            <a:r>
+              <a:rPr sz="1800" b="0">
+                <a:solidFill>
+                  <a:srgbClr val="000000"/>
+                </a:solidFill>
+              </a:rPr>
+              <a:t>Python 3.10 notebooks tested</a:t>
             </a:r>
           </a:p>
         </p:txBody>
@@ -2829,6 +2867,7 @@
           <a:lstStyle xmlns:a="http://schemas.openxmlformats.org/drawingml/2006/main"/>
           <a:p xmlns:a="http://schemas.openxmlformats.org/drawingml/2006/main">
             <a:pPr algn="l">
+              <a:buNone/>
               <a:defRPr sz="2250" b="1">
                 <a:solidFill>
                   <a:srgbClr val="FF6B35"/>
@@ -2841,7 +2880,7 @@
                   <a:srgbClr val="FF6B35"/>
                 </a:solidFill>
               </a:rPr>
-              <a:t>Fallback path</a:t>
+              <a:t>Organizer path</a:t>
             </a:r>
           </a:p>
         </p:txBody>
@@ -2879,6 +2918,7 @@
           <a:lstStyle xmlns:a="http://schemas.openxmlformats.org/drawingml/2006/main"/>
           <a:p xmlns:a="http://schemas.openxmlformats.org/drawingml/2006/main">
             <a:pPr algn="l">
+              <a:buNone/>
               <a:defRPr sz="1800" b="0">
                 <a:solidFill>
                   <a:srgbClr val="000000"/>
@@ -2891,11 +2931,20 @@
                   <a:srgbClr val="000000"/>
                 </a:solidFill>
               </a:rPr>
-              <a:t>• Load data/raw/dgat_predictions.csv</a:t>
-            </a:r>
-          </a:p>
-          <a:p xmlns:a="http://schemas.openxmlformats.org/drawingml/2006/main">
-            <a:pPr algn="l">
+              <a:t>• </a:t>
+            </a:r>
+            <a:r>
+              <a:rPr sz="1800" b="0">
+                <a:solidFill>
+                  <a:srgbClr val="000000"/>
+                </a:solidFill>
+              </a:rPr>
+              <a:t>Python 3.11 DGAT environment</a:t>
+            </a:r>
+          </a:p>
+          <a:p xmlns:a="http://schemas.openxmlformats.org/drawingml/2006/main">
+            <a:pPr algn="l">
+              <a:buNone/>
               <a:defRPr sz="1800" b="0">
                 <a:solidFill>
                   <a:srgbClr val="000000"/>
@@ -2908,11 +2957,20 @@
                   <a:srgbClr val="000000"/>
                 </a:solidFill>
               </a:rPr>
-              <a:t>• Continue visualization and evaluation</a:t>
-            </a:r>
-          </a:p>
-          <a:p xmlns:a="http://schemas.openxmlformats.org/drawingml/2006/main">
-            <a:pPr algn="l">
+              <a:t>• </a:t>
+            </a:r>
+            <a:r>
+              <a:rPr sz="1800" b="0">
+                <a:solidFill>
+                  <a:srgbClr val="000000"/>
+                </a:solidFill>
+              </a:rPr>
+              <a:t>GPU/HPC arranged and preflighted</a:t>
+            </a:r>
+          </a:p>
+          <a:p xmlns:a="http://schemas.openxmlformats.org/drawingml/2006/main">
+            <a:pPr algn="l">
+              <a:buNone/>
               <a:defRPr sz="1800" b="0">
                 <a:solidFill>
                   <a:srgbClr val="000000"/>
@@ -2925,7 +2983,15 @@
                   <a:srgbClr val="000000"/>
                 </a:solidFill>
               </a:rPr>
-              <a:t>• Use synthetic data only for environment checks</a:t>
+              <a:t>• </a:t>
+            </a:r>
+            <a:r>
+              <a:rPr sz="1800" b="0">
+                <a:solidFill>
+                  <a:srgbClr val="000000"/>
+                </a:solidFill>
+              </a:rPr>
+              <a:t>Official inference run before class</a:t>
             </a:r>
           </a:p>
         </p:txBody>
@@ -2994,6 +3060,7 @@
           <a:lstStyle xmlns:a="http://schemas.openxmlformats.org/drawingml/2006/main"/>
           <a:p xmlns:a="http://schemas.openxmlformats.org/drawingml/2006/main">
             <a:pPr algn="l">
+              <a:buNone/>
               <a:defRPr sz="1800" b="0">
                 <a:solidFill>
                   <a:srgbClr val="000000"/>
@@ -3006,14 +3073,14 @@
                   <a:srgbClr val="000000"/>
                 </a:solidFill>
               </a:rPr>
-              <a:t>The learning objective is the end-to-end reasoning, not debugging model installation in real time.</a:t>
+              <a:t>A missing prediction table stops clearly—it never triggers a silent fitted baseline.</a:t>
             </a:r>
           </a:p>
         </p:txBody>
       </p:sp>
       <p:cxnSp>
         <p:nvCxnSpPr>
-          <p:cNvPr id="21" name="rule"/>
+          <p:cNvPr id="41" name="rule"/>
           <p:cNvCxnSpPr/>
           <p:nvPr/>
         </p:nvCxnSpPr>
@@ -3066,6 +3133,7 @@
           <a:lstStyle xmlns:a="http://schemas.openxmlformats.org/drawingml/2006/main"/>
           <a:p xmlns:a="http://schemas.openxmlformats.org/drawingml/2006/main">
             <a:pPr algn="l">
+              <a:buNone/>
               <a:defRPr sz="1050" b="0">
                 <a:solidFill>
                   <a:srgbClr val="555555"/>
@@ -3114,7 +3182,7 @@
       </p:grpSpPr>
       <p:sp>
         <p:nvSpPr>
-          <p:cNvPr id="1" name="text">
+          <p:cNvPr id="15" name="text">
             <a:extLst xmlns:a="http://schemas.openxmlformats.org/drawingml/2006/main">
               <a:ext uri="{FF2B5EF4-FFF2-40B4-BE49-F238E27FC236}">
                 <a16:creationId xmlns:a16="http://schemas.microsoft.com/office/drawing/2014/main" id="{06C3CEB9-331C-465C-8ED0-CB3278226126}"/>
@@ -3145,6 +3213,7 @@
           <a:lstStyle xmlns:a="http://schemas.openxmlformats.org/drawingml/2006/main"/>
           <a:p xmlns:a="http://schemas.openxmlformats.org/drawingml/2006/main">
             <a:pPr algn="l">
+              <a:buNone/>
               <a:defRPr sz="1200" b="1">
                 <a:solidFill>
                   <a:srgbClr val="555555"/>
@@ -3195,6 +3264,7 @@
           <a:lstStyle xmlns:a="http://schemas.openxmlformats.org/drawingml/2006/main"/>
           <a:p xmlns:a="http://schemas.openxmlformats.org/drawingml/2006/main">
             <a:pPr algn="l">
+              <a:buNone/>
               <a:defRPr sz="3150" b="0">
                 <a:solidFill>
                   <a:srgbClr val="000000"/>
@@ -3207,7 +3277,7 @@
                   <a:srgbClr val="000000"/>
                 </a:solidFill>
               </a:rPr>
-              <a:t>Before 1 July: materials to lock down</a:t>
+              <a:t>Before release: readiness gates</a:t>
             </a:r>
           </a:p>
         </p:txBody>
@@ -3245,6 +3315,7 @@
           <a:lstStyle xmlns:a="http://schemas.openxmlformats.org/drawingml/2006/main"/>
           <a:p xmlns:a="http://schemas.openxmlformats.org/drawingml/2006/main">
             <a:pPr algn="r">
+              <a:buNone/>
               <a:defRPr sz="1200" b="0">
                 <a:solidFill>
                   <a:srgbClr val="555555"/>
@@ -3264,7 +3335,7 @@
       </p:sp>
       <p:graphicFrame>
         <p:nvGraphicFramePr>
-          <p:cNvPr id="11" name=""/>
+          <p:cNvPr id="25" name=""/>
           <p:cNvGraphicFramePr/>
           <p:nvPr/>
         </p:nvGraphicFramePr>
@@ -3353,7 +3424,7 @@
                             <a:srgbClr val="000000"/>
                           </a:solidFill>
                         </a:rPr>
-                        <a:t>DGAT assets downloaded; tutorial CSVs generated</a:t>
+                        <a:t>Data + predictions sent ≥1 week early</a:t>
                       </a:r>
                     </a:p>
                   </a:txBody>
@@ -3389,7 +3460,7 @@
                             <a:srgbClr val="000000"/>
                           </a:solidFill>
                         </a:rPr>
-                        <a:t>Checkpoint path and prediction command tested</a:t>
+                        <a:t>Python 3.11 DGAT env passes preflight</a:t>
                       </a:r>
                     </a:p>
                   </a:txBody>
@@ -3425,7 +3496,7 @@
                             <a:srgbClr val="000000"/>
                           </a:solidFill>
                         </a:rPr>
-                        <a:t>All three run top-to-bottom from a clean environment</a:t>
+                        <a:t>Python 3.10 path runs clean; default is DGAT output</a:t>
                       </a:r>
                     </a:p>
                   </a:txBody>
@@ -3461,7 +3532,7 @@
                             <a:srgbClr val="000000"/>
                           </a:solidFill>
                         </a:rPr>
-                        <a:t>Precomputed predictions available</a:t>
+                        <a:t>Provenance retained; ridge labeled baseline</a:t>
                       </a:r>
                     </a:p>
                   </a:txBody>
@@ -3497,7 +3568,7 @@
                             <a:srgbClr val="000000"/>
                           </a:solidFill>
                         </a:rPr>
-                        <a:t>Runtime, license, and troubleshooting notes documented</a:t>
+                        <a:t>Runtime + peak memory measured and shared</a:t>
                       </a:r>
                     </a:p>
                   </a:txBody>
@@ -3541,6 +3612,7 @@
           <a:lstStyle xmlns:a="http://schemas.openxmlformats.org/drawingml/2006/main"/>
           <a:p xmlns:a="http://schemas.openxmlformats.org/drawingml/2006/main">
             <a:pPr algn="l">
+              <a:buNone/>
               <a:defRPr sz="2100" b="0">
                 <a:solidFill>
                   <a:srgbClr val="000000"/>
@@ -3553,14 +3625,14 @@
                   <a:srgbClr val="000000"/>
                 </a:solidFill>
               </a:rPr>
-              <a:t>Deliverable: a GitHub repo reviewers can run and participants can recover from.</a:t>
+              <a:t>Deliverable: setup completed before travel and results participants can interpret honestly.</a:t>
             </a:r>
           </a:p>
         </p:txBody>
       </p:sp>
       <p:cxnSp>
         <p:nvCxnSpPr>
-          <p:cNvPr id="13" name="rule"/>
+          <p:cNvPr id="27" name="rule"/>
           <p:cNvCxnSpPr/>
           <p:nvPr/>
         </p:nvCxnSpPr>
@@ -3613,6 +3685,7 @@
           <a:lstStyle xmlns:a="http://schemas.openxmlformats.org/drawingml/2006/main"/>
           <a:p xmlns:a="http://schemas.openxmlformats.org/drawingml/2006/main">
             <a:pPr algn="l">
+              <a:buNone/>
               <a:defRPr sz="1050" b="0">
                 <a:solidFill>
                   <a:srgbClr val="555555"/>
@@ -3661,7 +3734,7 @@
       </p:grpSpPr>
       <p:sp>
         <p:nvSpPr>
-          <p:cNvPr id="1" name="text">
+          <p:cNvPr id="8" name="text">
             <a:extLst xmlns:a="http://schemas.openxmlformats.org/drawingml/2006/main">
               <a:ext uri="{FF2B5EF4-FFF2-40B4-BE49-F238E27FC236}">
                 <a16:creationId xmlns:a16="http://schemas.microsoft.com/office/drawing/2014/main" id="{FFD9F2BA-C061-4B3B-8675-AE4D38EE1FCE}"/>
@@ -3692,6 +3765,7 @@
           <a:lstStyle xmlns:a="http://schemas.openxmlformats.org/drawingml/2006/main"/>
           <a:p xmlns:a="http://schemas.openxmlformats.org/drawingml/2006/main">
             <a:pPr algn="l">
+              <a:buNone/>
               <a:defRPr sz="2400" b="0">
                 <a:solidFill>
                   <a:srgbClr val="555555"/>
@@ -3742,6 +3816,7 @@
           <a:lstStyle xmlns:a="http://schemas.openxmlformats.org/drawingml/2006/main"/>
           <a:p xmlns:a="http://schemas.openxmlformats.org/drawingml/2006/main">
             <a:pPr algn="l">
+              <a:buNone/>
               <a:defRPr sz="3600" b="0">
                 <a:solidFill>
                   <a:srgbClr val="000000"/>
@@ -3792,6 +3867,7 @@
           <a:lstStyle xmlns:a="http://schemas.openxmlformats.org/drawingml/2006/main"/>
           <a:p xmlns:a="http://schemas.openxmlformats.org/drawingml/2006/main">
             <a:pPr algn="l">
+              <a:buNone/>
               <a:defRPr sz="1800" b="1">
                 <a:solidFill>
                   <a:srgbClr val="000000"/>
@@ -3842,6 +3918,7 @@
           <a:lstStyle xmlns:a="http://schemas.openxmlformats.org/drawingml/2006/main"/>
           <a:p xmlns:a="http://schemas.openxmlformats.org/drawingml/2006/main">
             <a:pPr algn="l">
+              <a:buNone/>
               <a:defRPr sz="1800" b="0">
                 <a:solidFill>
                   <a:srgbClr val="555555"/>
@@ -3892,6 +3969,7 @@
           <a:lstStyle xmlns:a="http://schemas.openxmlformats.org/drawingml/2006/main"/>
           <a:p xmlns:a="http://schemas.openxmlformats.org/drawingml/2006/main">
             <a:pPr algn="l">
+              <a:buNone/>
               <a:defRPr sz="1800" b="1">
                 <a:solidFill>
                   <a:srgbClr val="000000"/>
@@ -3942,6 +4020,7 @@
           <a:lstStyle xmlns:a="http://schemas.openxmlformats.org/drawingml/2006/main"/>
           <a:p xmlns:a="http://schemas.openxmlformats.org/drawingml/2006/main">
             <a:pPr algn="l">
+              <a:buNone/>
               <a:defRPr sz="1800" b="0">
                 <a:solidFill>
                   <a:srgbClr val="555555"/>
@@ -4021,7 +4100,7 @@
       </p:grpSpPr>
       <p:sp>
         <p:nvSpPr>
-          <p:cNvPr id="1" name="text">
+          <p:cNvPr id="15" name="text">
             <a:extLst xmlns:a="http://schemas.openxmlformats.org/drawingml/2006/main">
               <a:ext uri="{FF2B5EF4-FFF2-40B4-BE49-F238E27FC236}">
                 <a16:creationId xmlns:a16="http://schemas.microsoft.com/office/drawing/2014/main" id="{57431DC2-95D4-49E4-ABD2-1CB77AC1C131}"/>
@@ -4052,6 +4131,7 @@
           <a:lstStyle xmlns:a="http://schemas.openxmlformats.org/drawingml/2006/main"/>
           <a:p xmlns:a="http://schemas.openxmlformats.org/drawingml/2006/main">
             <a:pPr algn="l">
+              <a:buNone/>
               <a:defRPr sz="1200" b="1">
                 <a:solidFill>
                   <a:srgbClr val="555555"/>
@@ -4102,6 +4182,7 @@
           <a:lstStyle xmlns:a="http://schemas.openxmlformats.org/drawingml/2006/main"/>
           <a:p xmlns:a="http://schemas.openxmlformats.org/drawingml/2006/main">
             <a:pPr algn="l">
+              <a:buNone/>
               <a:defRPr sz="3150" b="0">
                 <a:solidFill>
                   <a:srgbClr val="000000"/>
@@ -4152,6 +4233,7 @@
           <a:lstStyle xmlns:a="http://schemas.openxmlformats.org/drawingml/2006/main"/>
           <a:p xmlns:a="http://schemas.openxmlformats.org/drawingml/2006/main">
             <a:pPr algn="r">
+              <a:buNone/>
               <a:defRPr sz="1200" b="0">
                 <a:solidFill>
                   <a:srgbClr val="555555"/>
@@ -4171,7 +4253,7 @@
       </p:sp>
       <p:graphicFrame>
         <p:nvGraphicFramePr>
-          <p:cNvPr id="11" name=""/>
+          <p:cNvPr id="25" name=""/>
           <p:cNvGraphicFramePr/>
           <p:nvPr/>
         </p:nvGraphicFramePr>
@@ -4335,7 +4417,7 @@
                             <a:srgbClr val="000000"/>
                           </a:solidFill>
                         </a:rPr>
-                        <a:t>Running DGAT protein inference workflows</a:t>
+                        <a:t>Using DGAT protein inference outputs</a:t>
                       </a:r>
                     </a:p>
                   </a:txBody>
@@ -4352,7 +4434,7 @@
                             <a:srgbClr val="000000"/>
                           </a:solidFill>
                         </a:rPr>
-                        <a:t>Prepare inputs, run or load DGAT predictions, generate spatial protein maps.</a:t>
+                        <a:t>Align inputs, load official DGAT predictions, generate spatial protein maps.</a:t>
                       </a:r>
                     </a:p>
                   </a:txBody>
@@ -4449,6 +4531,7 @@
           <a:lstStyle xmlns:a="http://schemas.openxmlformats.org/drawingml/2006/main"/>
           <a:p xmlns:a="http://schemas.openxmlformats.org/drawingml/2006/main">
             <a:pPr algn="l">
+              <a:buNone/>
               <a:defRPr sz="2100" b="0">
                 <a:solidFill>
                   <a:srgbClr val="000000"/>
@@ -4461,14 +4544,14 @@
                   <a:srgbClr val="000000"/>
                 </a:solidFill>
               </a:rPr>
-              <a:t>Keep the live DGAT run short; use precomputed predictions as the continuity path.</a:t>
+              <a:t>Default live path: load organizer-provided DGAT predictions; run official inference before class.</a:t>
             </a:r>
           </a:p>
         </p:txBody>
       </p:sp>
       <p:cxnSp>
         <p:nvCxnSpPr>
-          <p:cNvPr id="13" name="rule"/>
+          <p:cNvPr id="27" name="rule"/>
           <p:cNvCxnSpPr/>
           <p:nvPr/>
         </p:nvCxnSpPr>
@@ -4521,6 +4604,7 @@
           <a:lstStyle xmlns:a="http://schemas.openxmlformats.org/drawingml/2006/main"/>
           <a:p xmlns:a="http://schemas.openxmlformats.org/drawingml/2006/main">
             <a:pPr algn="l">
+              <a:buNone/>
               <a:defRPr sz="1050" b="0">
                 <a:solidFill>
                   <a:srgbClr val="555555"/>
@@ -4569,7 +4653,7 @@
       </p:grpSpPr>
       <p:sp>
         <p:nvSpPr>
-          <p:cNvPr id="1" name="text">
+          <p:cNvPr id="42" name="text">
             <a:extLst xmlns:a="http://schemas.openxmlformats.org/drawingml/2006/main">
               <a:ext uri="{FF2B5EF4-FFF2-40B4-BE49-F238E27FC236}">
                 <a16:creationId xmlns:a16="http://schemas.microsoft.com/office/drawing/2014/main" id="{B0DB1FAF-C7C1-422D-B8FC-6EC04991E679}"/>
@@ -4600,6 +4684,7 @@
           <a:lstStyle xmlns:a="http://schemas.openxmlformats.org/drawingml/2006/main"/>
           <a:p xmlns:a="http://schemas.openxmlformats.org/drawingml/2006/main">
             <a:pPr algn="l">
+              <a:buNone/>
               <a:defRPr sz="1200" b="1">
                 <a:solidFill>
                   <a:srgbClr val="555555"/>
@@ -4650,6 +4735,7 @@
           <a:lstStyle xmlns:a="http://schemas.openxmlformats.org/drawingml/2006/main"/>
           <a:p xmlns:a="http://schemas.openxmlformats.org/drawingml/2006/main">
             <a:pPr algn="l">
+              <a:buNone/>
               <a:defRPr sz="3150" b="0">
                 <a:solidFill>
                   <a:srgbClr val="000000"/>
@@ -4700,6 +4786,7 @@
           <a:lstStyle xmlns:a="http://schemas.openxmlformats.org/drawingml/2006/main"/>
           <a:p xmlns:a="http://schemas.openxmlformats.org/drawingml/2006/main">
             <a:pPr algn="r">
+              <a:buNone/>
               <a:defRPr sz="1200" b="0">
                 <a:solidFill>
                   <a:srgbClr val="555555"/>
@@ -4750,6 +4837,7 @@
           <a:lstStyle xmlns:a="http://schemas.openxmlformats.org/drawingml/2006/main"/>
           <a:p xmlns:a="http://schemas.openxmlformats.org/drawingml/2006/main">
             <a:pPr algn="l">
+              <a:buNone/>
               <a:defRPr sz="2550" b="1">
                 <a:solidFill>
                   <a:srgbClr val="000000"/>
@@ -4800,6 +4888,7 @@
           <a:lstStyle xmlns:a="http://schemas.openxmlformats.org/drawingml/2006/main"/>
           <a:p xmlns:a="http://schemas.openxmlformats.org/drawingml/2006/main">
             <a:pPr algn="l">
+              <a:buNone/>
               <a:defRPr sz="1950" b="0">
                 <a:solidFill>
                   <a:srgbClr val="555555"/>
@@ -4819,7 +4908,7 @@
       </p:sp>
       <p:cxnSp>
         <p:nvCxnSpPr>
-          <p:cNvPr id="27" name="rule"/>
+          <p:cNvPr id="67" name="rule"/>
           <p:cNvCxnSpPr/>
           <p:nvPr/>
         </p:nvCxnSpPr>
@@ -4872,6 +4961,7 @@
           <a:lstStyle xmlns:a="http://schemas.openxmlformats.org/drawingml/2006/main"/>
           <a:p xmlns:a="http://schemas.openxmlformats.org/drawingml/2006/main">
             <a:pPr algn="l">
+              <a:buNone/>
               <a:defRPr sz="2550" b="1">
                 <a:solidFill>
                   <a:srgbClr val="000000"/>
@@ -4922,6 +5012,7 @@
           <a:lstStyle xmlns:a="http://schemas.openxmlformats.org/drawingml/2006/main"/>
           <a:p xmlns:a="http://schemas.openxmlformats.org/drawingml/2006/main">
             <a:pPr algn="l">
+              <a:buNone/>
               <a:defRPr sz="1950" b="0">
                 <a:solidFill>
                   <a:srgbClr val="555555"/>
@@ -4941,7 +5032,7 @@
       </p:sp>
       <p:cxnSp>
         <p:nvCxnSpPr>
-          <p:cNvPr id="30" name="rule"/>
+          <p:cNvPr id="70" name="rule"/>
           <p:cNvCxnSpPr/>
           <p:nvPr/>
         </p:nvCxnSpPr>
@@ -4994,6 +5085,7 @@
           <a:lstStyle xmlns:a="http://schemas.openxmlformats.org/drawingml/2006/main"/>
           <a:p xmlns:a="http://schemas.openxmlformats.org/drawingml/2006/main">
             <a:pPr algn="l">
+              <a:buNone/>
               <a:defRPr sz="2550" b="1">
                 <a:solidFill>
                   <a:srgbClr val="000000"/>
@@ -5044,6 +5136,7 @@
           <a:lstStyle xmlns:a="http://schemas.openxmlformats.org/drawingml/2006/main"/>
           <a:p xmlns:a="http://schemas.openxmlformats.org/drawingml/2006/main">
             <a:pPr algn="l">
+              <a:buNone/>
               <a:defRPr sz="1950" b="0">
                 <a:solidFill>
                   <a:srgbClr val="555555"/>
@@ -5063,7 +5156,7 @@
       </p:sp>
       <p:cxnSp>
         <p:nvCxnSpPr>
-          <p:cNvPr id="33" name="rule"/>
+          <p:cNvPr id="73" name="rule"/>
           <p:cNvCxnSpPr/>
           <p:nvPr/>
         </p:nvCxnSpPr>
@@ -5116,6 +5209,7 @@
           <a:lstStyle xmlns:a="http://schemas.openxmlformats.org/drawingml/2006/main"/>
           <a:p xmlns:a="http://schemas.openxmlformats.org/drawingml/2006/main">
             <a:pPr algn="l">
+              <a:buNone/>
               <a:defRPr sz="2550" b="1">
                 <a:solidFill>
                   <a:srgbClr val="000000"/>
@@ -5166,6 +5260,7 @@
           <a:lstStyle xmlns:a="http://schemas.openxmlformats.org/drawingml/2006/main"/>
           <a:p xmlns:a="http://schemas.openxmlformats.org/drawingml/2006/main">
             <a:pPr algn="l">
+              <a:buNone/>
               <a:defRPr sz="1950" b="0">
                 <a:solidFill>
                   <a:srgbClr val="555555"/>
@@ -5185,7 +5280,7 @@
       </p:sp>
       <p:cxnSp>
         <p:nvCxnSpPr>
-          <p:cNvPr id="36" name="rule"/>
+          <p:cNvPr id="76" name="rule"/>
           <p:cNvCxnSpPr/>
           <p:nvPr/>
         </p:nvCxnSpPr>
@@ -5238,6 +5333,7 @@
           <a:lstStyle xmlns:a="http://schemas.openxmlformats.org/drawingml/2006/main"/>
           <a:p xmlns:a="http://schemas.openxmlformats.org/drawingml/2006/main">
             <a:pPr algn="l">
+              <a:buNone/>
               <a:defRPr sz="2550" b="1">
                 <a:solidFill>
                   <a:srgbClr val="000000"/>
@@ -5288,6 +5384,7 @@
           <a:lstStyle xmlns:a="http://schemas.openxmlformats.org/drawingml/2006/main"/>
           <a:p xmlns:a="http://schemas.openxmlformats.org/drawingml/2006/main">
             <a:pPr algn="l">
+              <a:buNone/>
               <a:defRPr sz="1950" b="0">
                 <a:solidFill>
                   <a:srgbClr val="555555"/>
@@ -5307,7 +5404,7 @@
       </p:sp>
       <p:cxnSp>
         <p:nvCxnSpPr>
-          <p:cNvPr id="39" name="rule"/>
+          <p:cNvPr id="79" name="rule"/>
           <p:cNvCxnSpPr/>
           <p:nvPr/>
         </p:nvCxnSpPr>
@@ -5360,7 +5457,7 @@
       </p:sp>
       <p:cxnSp>
         <p:nvCxnSpPr>
-          <p:cNvPr id="41" name="rule"/>
+          <p:cNvPr id="81" name="rule"/>
           <p:cNvCxnSpPr/>
           <p:nvPr/>
         </p:nvCxnSpPr>
@@ -5413,6 +5510,7 @@
           <a:lstStyle xmlns:a="http://schemas.openxmlformats.org/drawingml/2006/main"/>
           <a:p xmlns:a="http://schemas.openxmlformats.org/drawingml/2006/main">
             <a:pPr algn="l">
+              <a:buNone/>
               <a:defRPr sz="1050" b="0">
                 <a:solidFill>
                   <a:srgbClr val="555555"/>
@@ -5461,7 +5559,7 @@
       </p:grpSpPr>
       <p:sp>
         <p:nvSpPr>
-          <p:cNvPr id="1" name="text">
+          <p:cNvPr id="44" name="text">
             <a:extLst xmlns:a="http://schemas.openxmlformats.org/drawingml/2006/main">
               <a:ext uri="{FF2B5EF4-FFF2-40B4-BE49-F238E27FC236}">
                 <a16:creationId xmlns:a16="http://schemas.microsoft.com/office/drawing/2014/main" id="{056FF2E2-4210-4B89-A2AF-5D29DF595EFB}"/>
@@ -5492,6 +5590,7 @@
           <a:lstStyle xmlns:a="http://schemas.openxmlformats.org/drawingml/2006/main"/>
           <a:p xmlns:a="http://schemas.openxmlformats.org/drawingml/2006/main">
             <a:pPr algn="l">
+              <a:buNone/>
               <a:defRPr sz="1200" b="1">
                 <a:solidFill>
                   <a:srgbClr val="555555"/>
@@ -5542,6 +5641,7 @@
           <a:lstStyle xmlns:a="http://schemas.openxmlformats.org/drawingml/2006/main"/>
           <a:p xmlns:a="http://schemas.openxmlformats.org/drawingml/2006/main">
             <a:pPr algn="l">
+              <a:buNone/>
               <a:defRPr sz="3150" b="0">
                 <a:solidFill>
                   <a:srgbClr val="000000"/>
@@ -5554,7 +5654,7 @@
                   <a:srgbClr val="000000"/>
                 </a:solidFill>
               </a:rPr>
-              <a:t>Use official DGAT assets as the default data path</a:t>
+              <a:t>Complete setup before the conference</a:t>
             </a:r>
           </a:p>
         </p:txBody>
@@ -5592,6 +5692,7 @@
           <a:lstStyle xmlns:a="http://schemas.openxmlformats.org/drawingml/2006/main"/>
           <a:p xmlns:a="http://schemas.openxmlformats.org/drawingml/2006/main">
             <a:pPr algn="r">
+              <a:buNone/>
               <a:defRPr sz="1200" b="0">
                 <a:solidFill>
                   <a:srgbClr val="555555"/>
@@ -5673,6 +5774,7 @@
           <a:lstStyle xmlns:a="http://schemas.openxmlformats.org/drawingml/2006/main"/>
           <a:p xmlns:a="http://schemas.openxmlformats.org/drawingml/2006/main">
             <a:pPr algn="l">
+              <a:buNone/>
               <a:defRPr sz="3000" b="1">
                 <a:solidFill>
                   <a:srgbClr val="000000"/>
@@ -5723,6 +5825,7 @@
           <a:lstStyle xmlns:a="http://schemas.openxmlformats.org/drawingml/2006/main"/>
           <a:p xmlns:a="http://schemas.openxmlformats.org/drawingml/2006/main">
             <a:pPr algn="l">
+              <a:buNone/>
               <a:defRPr sz="1950" b="1">
                 <a:solidFill>
                   <a:srgbClr val="000000"/>
@@ -5735,7 +5838,7 @@
                   <a:srgbClr val="000000"/>
                 </a:solidFill>
               </a:rPr>
-              <a:t>Clone DGAT</a:t>
+              <a:t>Create tutorial env</a:t>
             </a:r>
           </a:p>
         </p:txBody>
@@ -5773,6 +5876,7 @@
           <a:lstStyle xmlns:a="http://schemas.openxmlformats.org/drawingml/2006/main"/>
           <a:p xmlns:a="http://schemas.openxmlformats.org/drawingml/2006/main">
             <a:pPr algn="l">
+              <a:buNone/>
               <a:defRPr sz="1350" b="0">
                 <a:solidFill>
                   <a:srgbClr val="555555"/>
@@ -5785,7 +5889,8 @@
                   <a:srgbClr val="555555"/>
                 </a:solidFill>
               </a:rPr>
-              <a:t>external/DGAT</a:t>
+              <a:t>Python 3.10
+16 GB RAM recommended</a:t>
             </a:r>
           </a:p>
         </p:txBody>
@@ -5854,6 +5959,7 @@
           <a:lstStyle xmlns:a="http://schemas.openxmlformats.org/drawingml/2006/main"/>
           <a:p xmlns:a="http://schemas.openxmlformats.org/drawingml/2006/main">
             <a:pPr algn="l">
+              <a:buNone/>
               <a:defRPr sz="3000" b="1">
                 <a:solidFill>
                   <a:srgbClr val="FF6B35"/>
@@ -5904,6 +6010,7 @@
           <a:lstStyle xmlns:a="http://schemas.openxmlformats.org/drawingml/2006/main"/>
           <a:p xmlns:a="http://schemas.openxmlformats.org/drawingml/2006/main">
             <a:pPr algn="l">
+              <a:buNone/>
               <a:defRPr sz="1950" b="1">
                 <a:solidFill>
                   <a:srgbClr val="000000"/>
@@ -5916,7 +6023,7 @@
                   <a:srgbClr val="000000"/>
                 </a:solidFill>
               </a:rPr>
-              <a:t>Download assets</a:t>
+              <a:t>Download data</a:t>
             </a:r>
           </a:p>
         </p:txBody>
@@ -5954,6 +6061,7 @@
           <a:lstStyle xmlns:a="http://schemas.openxmlformats.org/drawingml/2006/main"/>
           <a:p xmlns:a="http://schemas.openxmlformats.org/drawingml/2006/main">
             <a:pPr algn="l">
+              <a:buNone/>
               <a:defRPr sz="1350" b="0">
                 <a:solidFill>
                   <a:srgbClr val="555555"/>
@@ -5966,11 +6074,12 @@
                   <a:srgbClr val="555555"/>
                 </a:solidFill>
               </a:rPr>
-              <a:t>DGAT_prediction_ST_data</a:t>
-            </a:r>
-          </a:p>
-          <a:p xmlns:a="http://schemas.openxmlformats.org/drawingml/2006/main">
-            <a:pPr algn="l">
+              <a:t>Run ≥24 h early</a:t>
+            </a:r>
+          </a:p>
+          <a:p xmlns:a="http://schemas.openxmlformats.org/drawingml/2006/main">
+            <a:pPr algn="l">
+              <a:buNone/>
               <a:defRPr sz="1350" b="0">
                 <a:solidFill>
                   <a:srgbClr val="555555"/>
@@ -5983,7 +6092,7 @@
                   <a:srgbClr val="555555"/>
                 </a:solidFill>
               </a:rPr>
-              <a:t>DGAT_pretrained_models</a:t>
+              <a:t>~15 min in review</a:t>
             </a:r>
           </a:p>
         </p:txBody>
@@ -6052,6 +6161,7 @@
           <a:lstStyle xmlns:a="http://schemas.openxmlformats.org/drawingml/2006/main"/>
           <a:p xmlns:a="http://schemas.openxmlformats.org/drawingml/2006/main">
             <a:pPr algn="l">
+              <a:buNone/>
               <a:defRPr sz="3000" b="1">
                 <a:solidFill>
                   <a:srgbClr val="000000"/>
@@ -6102,6 +6212,7 @@
           <a:lstStyle xmlns:a="http://schemas.openxmlformats.org/drawingml/2006/main"/>
           <a:p xmlns:a="http://schemas.openxmlformats.org/drawingml/2006/main">
             <a:pPr algn="l">
+              <a:buNone/>
               <a:defRPr sz="1950" b="1">
                 <a:solidFill>
                   <a:srgbClr val="000000"/>
@@ -6114,7 +6225,7 @@
                   <a:srgbClr val="000000"/>
                 </a:solidFill>
               </a:rPr>
-              <a:t>Prepare tutorial CSVs</a:t>
+              <a:t>Add predictions</a:t>
             </a:r>
           </a:p>
         </p:txBody>
@@ -6152,6 +6263,7 @@
           <a:lstStyle xmlns:a="http://schemas.openxmlformats.org/drawingml/2006/main"/>
           <a:p xmlns:a="http://schemas.openxmlformats.org/drawingml/2006/main">
             <a:pPr algn="l">
+              <a:buNone/>
               <a:defRPr sz="1350" b="0">
                 <a:solidFill>
                   <a:srgbClr val="555555"/>
@@ -6164,7 +6276,8 @@
                   <a:srgbClr val="555555"/>
                 </a:solidFill>
               </a:rPr>
-              <a:t>scripts/prepare_dgat_data.py</a:t>
+              <a:t>data/raw/
+dgat_predictions.csv</a:t>
             </a:r>
           </a:p>
         </p:txBody>
@@ -6233,6 +6346,7 @@
           <a:lstStyle xmlns:a="http://schemas.openxmlformats.org/drawingml/2006/main"/>
           <a:p xmlns:a="http://schemas.openxmlformats.org/drawingml/2006/main">
             <a:pPr algn="l">
+              <a:buNone/>
               <a:defRPr sz="3000" b="1">
                 <a:solidFill>
                   <a:srgbClr val="000000"/>
@@ -6283,6 +6397,7 @@
           <a:lstStyle xmlns:a="http://schemas.openxmlformats.org/drawingml/2006/main"/>
           <a:p xmlns:a="http://schemas.openxmlformats.org/drawingml/2006/main">
             <a:pPr algn="l">
+              <a:buNone/>
               <a:defRPr sz="1950" b="1">
                 <a:solidFill>
                   <a:srgbClr val="000000"/>
@@ -6333,6 +6448,7 @@
           <a:lstStyle xmlns:a="http://schemas.openxmlformats.org/drawingml/2006/main"/>
           <a:p xmlns:a="http://schemas.openxmlformats.org/drawingml/2006/main">
             <a:pPr algn="l">
+              <a:buNone/>
               <a:defRPr sz="1350" b="0">
                 <a:solidFill>
                   <a:srgbClr val="555555"/>
@@ -6383,6 +6499,7 @@
           <a:lstStyle xmlns:a="http://schemas.openxmlformats.org/drawingml/2006/main"/>
           <a:p xmlns:a="http://schemas.openxmlformats.org/drawingml/2006/main">
             <a:pPr algn="l">
+              <a:buNone/>
               <a:defRPr sz="2100" b="0">
                 <a:solidFill>
                   <a:srgbClr val="000000"/>
@@ -6395,14 +6512,14 @@
                   <a:srgbClr val="000000"/>
                 </a:solidFill>
               </a:rPr>
-              <a:t>The synthetic path remains only for environment checks before DGAT data is downloaded.</a:t>
+              <a:t>Official inference uses a separate Python 3.11 environment; prepare it before class or on HPC.</a:t>
             </a:r>
           </a:p>
         </p:txBody>
       </p:sp>
       <p:cxnSp>
         <p:nvCxnSpPr>
-          <p:cNvPr id="43" name="rule"/>
+          <p:cNvPr id="85" name="rule"/>
           <p:cNvCxnSpPr/>
           <p:nvPr/>
         </p:nvCxnSpPr>
@@ -6455,6 +6572,7 @@
           <a:lstStyle xmlns:a="http://schemas.openxmlformats.org/drawingml/2006/main"/>
           <a:p xmlns:a="http://schemas.openxmlformats.org/drawingml/2006/main">
             <a:pPr algn="l">
+              <a:buNone/>
               <a:defRPr sz="1050" b="0">
                 <a:solidFill>
                   <a:srgbClr val="555555"/>
@@ -6503,7 +6621,7 @@
       </p:grpSpPr>
       <p:sp>
         <p:nvSpPr>
-          <p:cNvPr id="1" name="text">
+          <p:cNvPr id="23" name="text">
             <a:extLst xmlns:a="http://schemas.openxmlformats.org/drawingml/2006/main">
               <a:ext uri="{FF2B5EF4-FFF2-40B4-BE49-F238E27FC236}">
                 <a16:creationId xmlns:a16="http://schemas.microsoft.com/office/drawing/2014/main" id="{6B0DC52A-12FD-44E4-A138-E4006052C368}"/>
@@ -6534,6 +6652,7 @@
           <a:lstStyle xmlns:a="http://schemas.openxmlformats.org/drawingml/2006/main"/>
           <a:p xmlns:a="http://schemas.openxmlformats.org/drawingml/2006/main">
             <a:pPr algn="l">
+              <a:buNone/>
               <a:defRPr sz="1200" b="1">
                 <a:solidFill>
                   <a:srgbClr val="555555"/>
@@ -6584,6 +6703,7 @@
           <a:lstStyle xmlns:a="http://schemas.openxmlformats.org/drawingml/2006/main"/>
           <a:p xmlns:a="http://schemas.openxmlformats.org/drawingml/2006/main">
             <a:pPr algn="l">
+              <a:buNone/>
               <a:defRPr sz="3150" b="0">
                 <a:solidFill>
                   <a:srgbClr val="000000"/>
@@ -6634,6 +6754,7 @@
           <a:lstStyle xmlns:a="http://schemas.openxmlformats.org/drawingml/2006/main"/>
           <a:p xmlns:a="http://schemas.openxmlformats.org/drawingml/2006/main">
             <a:pPr algn="r">
+              <a:buNone/>
               <a:defRPr sz="1200" b="0">
                 <a:solidFill>
                   <a:srgbClr val="555555"/>
@@ -6684,6 +6805,7 @@
           <a:lstStyle xmlns:a="http://schemas.openxmlformats.org/drawingml/2006/main"/>
           <a:p xmlns:a="http://schemas.openxmlformats.org/drawingml/2006/main">
             <a:pPr algn="l">
+              <a:buNone/>
               <a:defRPr sz="2250" b="1">
                 <a:solidFill>
                   <a:srgbClr val="000000"/>
@@ -6696,7 +6818,7 @@
                   <a:srgbClr val="000000"/>
                 </a:solidFill>
               </a:rPr>
-              <a:t>Inputs in data/raw</a:t>
+              <a:t>Files used by notebooks</a:t>
             </a:r>
           </a:p>
         </p:txBody>
@@ -6734,6 +6856,7 @@
           <a:lstStyle xmlns:a="http://schemas.openxmlformats.org/drawingml/2006/main"/>
           <a:p xmlns:a="http://schemas.openxmlformats.org/drawingml/2006/main">
             <a:pPr algn="l">
+              <a:buNone/>
               <a:defRPr sz="1725" b="0">
                 <a:solidFill>
                   <a:srgbClr val="000000"/>
@@ -6746,11 +6869,20 @@
                   <a:srgbClr val="000000"/>
                 </a:solidFill>
               </a:rPr>
-              <a:t>• spots.csv: spot_id, x, y</a:t>
-            </a:r>
-          </a:p>
-          <a:p xmlns:a="http://schemas.openxmlformats.org/drawingml/2006/main">
-            <a:pPr algn="l">
+              <a:t>• </a:t>
+            </a:r>
+            <a:r>
+              <a:rPr sz="1725" b="0">
+                <a:solidFill>
+                  <a:srgbClr val="000000"/>
+                </a:solidFill>
+              </a:rPr>
+              <a:t>RNA/ADT .h5ad: observed matrices</a:t>
+            </a:r>
+          </a:p>
+          <a:p xmlns:a="http://schemas.openxmlformats.org/drawingml/2006/main">
+            <a:pPr algn="l">
+              <a:buNone/>
               <a:defRPr sz="1725" b="0">
                 <a:solidFill>
                   <a:srgbClr val="000000"/>
@@ -6763,11 +6895,20 @@
                   <a:srgbClr val="000000"/>
                 </a:solidFill>
               </a:rPr>
-              <a:t>• transcripts.csv: spots × genes</a:t>
-            </a:r>
-          </a:p>
-          <a:p xmlns:a="http://schemas.openxmlformats.org/drawingml/2006/main">
-            <a:pPr algn="l">
+              <a:t>• </a:t>
+            </a:r>
+            <a:r>
+              <a:rPr sz="1725" b="0">
+                <a:solidFill>
+                  <a:srgbClr val="000000"/>
+                </a:solidFill>
+              </a:rPr>
+              <a:t>dgat_predictions.csv: official DGAT output</a:t>
+            </a:r>
+          </a:p>
+          <a:p xmlns:a="http://schemas.openxmlformats.org/drawingml/2006/main">
+            <a:pPr algn="l">
+              <a:buNone/>
               <a:defRPr sz="1725" b="0">
                 <a:solidFill>
                   <a:srgbClr val="000000"/>
@@ -6780,11 +6921,20 @@
                   <a:srgbClr val="000000"/>
                 </a:solidFill>
               </a:rPr>
-              <a:t>• proteins.csv: observed proteins</a:t>
-            </a:r>
-          </a:p>
-          <a:p xmlns:a="http://schemas.openxmlformats.org/drawingml/2006/main">
-            <a:pPr algn="l">
+              <a:t>• </a:t>
+            </a:r>
+            <a:r>
+              <a:rPr sz="1725" b="0">
+                <a:solidFill>
+                  <a:srgbClr val="000000"/>
+                </a:solidFill>
+              </a:rPr>
+              <a:t>predicted_proteins.metadata.json: provenance</a:t>
+            </a:r>
+          </a:p>
+          <a:p xmlns:a="http://schemas.openxmlformats.org/drawingml/2006/main">
+            <a:pPr algn="l">
+              <a:buNone/>
               <a:defRPr sz="1725" b="0">
                 <a:solidFill>
                   <a:srgbClr val="000000"/>
@@ -6797,7 +6947,15 @@
                   <a:srgbClr val="000000"/>
                 </a:solidFill>
               </a:rPr>
-              <a:t>• dgat_predictions.csv: inferred proteins</a:t>
+              <a:t>• </a:t>
+            </a:r>
+            <a:r>
+              <a:rPr sz="1725" b="0">
+                <a:solidFill>
+                  <a:srgbClr val="000000"/>
+                </a:solidFill>
+              </a:rPr>
+              <a:t>Align rows by spot; columns by protein</a:t>
             </a:r>
           </a:p>
         </p:txBody>
@@ -6866,6 +7024,7 @@
           <a:lstStyle xmlns:a="http://schemas.openxmlformats.org/drawingml/2006/main"/>
           <a:p xmlns:a="http://schemas.openxmlformats.org/drawingml/2006/main">
             <a:pPr algn="l">
+              <a:buNone/>
               <a:defRPr sz="2250" b="1">
                 <a:solidFill>
                   <a:srgbClr val="000000"/>
@@ -6885,7 +7044,7 @@
       </p:sp>
       <p:graphicFrame>
         <p:nvGraphicFramePr>
-          <p:cNvPr id="19" name=""/>
+          <p:cNvPr id="41" name=""/>
           <p:cNvGraphicFramePr/>
           <p:nvPr/>
         </p:nvGraphicFramePr>
@@ -7236,6 +7395,7 @@
           <a:lstStyle xmlns:a="http://schemas.openxmlformats.org/drawingml/2006/main"/>
           <a:p xmlns:a="http://schemas.openxmlformats.org/drawingml/2006/main">
             <a:pPr algn="l">
+              <a:buNone/>
               <a:defRPr sz="1800" b="0">
                 <a:solidFill>
                   <a:srgbClr val="555555"/>
@@ -7255,7 +7415,7 @@
       </p:sp>
       <p:cxnSp>
         <p:nvCxnSpPr>
-          <p:cNvPr id="21" name="rule"/>
+          <p:cNvPr id="43" name="rule"/>
           <p:cNvCxnSpPr/>
           <p:nvPr/>
         </p:nvCxnSpPr>
@@ -7308,6 +7468,7 @@
           <a:lstStyle xmlns:a="http://schemas.openxmlformats.org/drawingml/2006/main"/>
           <a:p xmlns:a="http://schemas.openxmlformats.org/drawingml/2006/main">
             <a:pPr algn="l">
+              <a:buNone/>
               <a:defRPr sz="1050" b="0">
                 <a:solidFill>
                   <a:srgbClr val="555555"/>
@@ -7356,7 +7517,7 @@
       </p:grpSpPr>
       <p:sp>
         <p:nvSpPr>
-          <p:cNvPr id="1" name="text">
+          <p:cNvPr id="36" name="text">
             <a:extLst xmlns:a="http://schemas.openxmlformats.org/drawingml/2006/main">
               <a:ext uri="{FF2B5EF4-FFF2-40B4-BE49-F238E27FC236}">
                 <a16:creationId xmlns:a16="http://schemas.microsoft.com/office/drawing/2014/main" id="{94507F38-24BC-4532-9F75-C575A6CF1C4C}"/>
@@ -7387,6 +7548,7 @@
           <a:lstStyle xmlns:a="http://schemas.openxmlformats.org/drawingml/2006/main"/>
           <a:p xmlns:a="http://schemas.openxmlformats.org/drawingml/2006/main">
             <a:pPr algn="l">
+              <a:buNone/>
               <a:defRPr sz="1200" b="1">
                 <a:solidFill>
                   <a:srgbClr val="555555"/>
@@ -7437,6 +7599,7 @@
           <a:lstStyle xmlns:a="http://schemas.openxmlformats.org/drawingml/2006/main"/>
           <a:p xmlns:a="http://schemas.openxmlformats.org/drawingml/2006/main">
             <a:pPr algn="l">
+              <a:buNone/>
               <a:defRPr sz="3150" b="0">
                 <a:solidFill>
                   <a:srgbClr val="000000"/>
@@ -7487,6 +7650,7 @@
           <a:lstStyle xmlns:a="http://schemas.openxmlformats.org/drawingml/2006/main"/>
           <a:p xmlns:a="http://schemas.openxmlformats.org/drawingml/2006/main">
             <a:pPr algn="r">
+              <a:buNone/>
               <a:defRPr sz="1200" b="0">
                 <a:solidFill>
                   <a:srgbClr val="555555"/>
@@ -7568,6 +7732,7 @@
           <a:lstStyle xmlns:a="http://schemas.openxmlformats.org/drawingml/2006/main"/>
           <a:p xmlns:a="http://schemas.openxmlformats.org/drawingml/2006/main">
             <a:pPr algn="l">
+              <a:buNone/>
               <a:defRPr sz="2250" b="1">
                 <a:solidFill>
                   <a:srgbClr val="000000"/>
@@ -7897,6 +8062,7 @@
           <a:lstStyle xmlns:a="http://schemas.openxmlformats.org/drawingml/2006/main"/>
           <a:p xmlns:a="http://schemas.openxmlformats.org/drawingml/2006/main">
             <a:pPr algn="l">
+              <a:buNone/>
               <a:defRPr sz="2025" b="0">
                 <a:solidFill>
                   <a:srgbClr val="000000"/>
@@ -7914,6 +8080,7 @@
           </a:p>
           <a:p xmlns:a="http://schemas.openxmlformats.org/drawingml/2006/main">
             <a:pPr algn="l">
+              <a:buNone/>
               <a:defRPr sz="2025" b="0">
                 <a:solidFill>
                   <a:srgbClr val="000000"/>
@@ -7926,11 +8093,20 @@
                   <a:srgbClr val="000000"/>
                 </a:solidFill>
               </a:rPr>
-              <a:t>• Load DGAT-derived tables</a:t>
-            </a:r>
-          </a:p>
-          <a:p xmlns:a="http://schemas.openxmlformats.org/drawingml/2006/main">
-            <a:pPr algn="l">
+              <a:t>• </a:t>
+            </a:r>
+            <a:r>
+              <a:rPr sz="2025" b="0">
+                <a:solidFill>
+                  <a:srgbClr val="000000"/>
+                </a:solidFill>
+              </a:rPr>
+              <a:t>Load official DGAT .h5ad data</a:t>
+            </a:r>
+          </a:p>
+          <a:p xmlns:a="http://schemas.openxmlformats.org/drawingml/2006/main">
+            <a:pPr algn="l">
+              <a:buNone/>
               <a:defRPr sz="2025" b="0">
                 <a:solidFill>
                   <a:srgbClr val="000000"/>
@@ -7948,6 +8124,7 @@
           </a:p>
           <a:p xmlns:a="http://schemas.openxmlformats.org/drawingml/2006/main">
             <a:pPr algn="l">
+              <a:buNone/>
               <a:defRPr sz="2025" b="0">
                 <a:solidFill>
                   <a:srgbClr val="000000"/>
@@ -7998,6 +8175,7 @@
           <a:lstStyle xmlns:a="http://schemas.openxmlformats.org/drawingml/2006/main"/>
           <a:p xmlns:a="http://schemas.openxmlformats.org/drawingml/2006/main">
             <a:pPr algn="l">
+              <a:buNone/>
               <a:defRPr sz="2100" b="0">
                 <a:solidFill>
                   <a:srgbClr val="555555"/>
@@ -8017,7 +8195,7 @@
       </p:sp>
       <p:cxnSp>
         <p:nvCxnSpPr>
-          <p:cNvPr id="35" name="rule"/>
+          <p:cNvPr id="69" name="rule"/>
           <p:cNvCxnSpPr/>
           <p:nvPr/>
         </p:nvCxnSpPr>
@@ -8070,6 +8248,7 @@
           <a:lstStyle xmlns:a="http://schemas.openxmlformats.org/drawingml/2006/main"/>
           <a:p xmlns:a="http://schemas.openxmlformats.org/drawingml/2006/main">
             <a:pPr algn="l">
+              <a:buNone/>
               <a:defRPr sz="1050" b="0">
                 <a:solidFill>
                   <a:srgbClr val="555555"/>
@@ -8118,7 +8297,7 @@
       </p:grpSpPr>
       <p:sp>
         <p:nvSpPr>
-          <p:cNvPr id="1" name="text">
+          <p:cNvPr id="44" name="text">
             <a:extLst xmlns:a="http://schemas.openxmlformats.org/drawingml/2006/main">
               <a:ext uri="{FF2B5EF4-FFF2-40B4-BE49-F238E27FC236}">
                 <a16:creationId xmlns:a16="http://schemas.microsoft.com/office/drawing/2014/main" id="{9E63A5CF-1F7F-404A-8D62-7969D420E280}"/>
@@ -8149,6 +8328,7 @@
           <a:lstStyle xmlns:a="http://schemas.openxmlformats.org/drawingml/2006/main"/>
           <a:p xmlns:a="http://schemas.openxmlformats.org/drawingml/2006/main">
             <a:pPr algn="l">
+              <a:buNone/>
               <a:defRPr sz="1200" b="1">
                 <a:solidFill>
                   <a:srgbClr val="555555"/>
@@ -8199,6 +8379,7 @@
           <a:lstStyle xmlns:a="http://schemas.openxmlformats.org/drawingml/2006/main"/>
           <a:p xmlns:a="http://schemas.openxmlformats.org/drawingml/2006/main">
             <a:pPr algn="l">
+              <a:buNone/>
               <a:defRPr sz="3150" b="0">
                 <a:solidFill>
                   <a:srgbClr val="000000"/>
@@ -8211,7 +8392,7 @@
                   <a:srgbClr val="000000"/>
                 </a:solidFill>
               </a:rPr>
-              <a:t>Session 2: DGAT inference without losing the room</a:t>
+              <a:t>Session 2: precomputed DGAT, no leakage</a:t>
             </a:r>
           </a:p>
         </p:txBody>
@@ -8249,6 +8430,7 @@
           <a:lstStyle xmlns:a="http://schemas.openxmlformats.org/drawingml/2006/main"/>
           <a:p xmlns:a="http://schemas.openxmlformats.org/drawingml/2006/main">
             <a:pPr algn="r">
+              <a:buNone/>
               <a:defRPr sz="1200" b="0">
                 <a:solidFill>
                   <a:srgbClr val="555555"/>
@@ -8330,6 +8512,7 @@
           <a:lstStyle xmlns:a="http://schemas.openxmlformats.org/drawingml/2006/main"/>
           <a:p xmlns:a="http://schemas.openxmlformats.org/drawingml/2006/main">
             <a:pPr algn="l">
+              <a:buNone/>
               <a:defRPr sz="2250" b="1">
                 <a:solidFill>
                   <a:srgbClr val="000000"/>
@@ -8380,6 +8563,7 @@
           <a:lstStyle xmlns:a="http://schemas.openxmlformats.org/drawingml/2006/main"/>
           <a:p xmlns:a="http://schemas.openxmlformats.org/drawingml/2006/main">
             <a:pPr algn="l">
+              <a:buNone/>
               <a:defRPr sz="1350" b="0">
                 <a:solidFill>
                   <a:srgbClr val="555555"/>
@@ -8399,7 +8583,7 @@
       </p:sp>
       <p:cxnSp>
         <p:nvCxnSpPr>
-          <p:cNvPr id="29" name="rule"/>
+          <p:cNvPr id="71" name="rule"/>
           <p:cNvCxnSpPr/>
           <p:nvPr/>
         </p:nvCxnSpPr>
@@ -8483,6 +8667,7 @@
           <a:lstStyle xmlns:a="http://schemas.openxmlformats.org/drawingml/2006/main"/>
           <a:p xmlns:a="http://schemas.openxmlformats.org/drawingml/2006/main">
             <a:pPr algn="l">
+              <a:buNone/>
               <a:defRPr sz="2250" b="1">
                 <a:solidFill>
                   <a:srgbClr val="000000"/>
@@ -8533,6 +8718,7 @@
           <a:lstStyle xmlns:a="http://schemas.openxmlformats.org/drawingml/2006/main"/>
           <a:p xmlns:a="http://schemas.openxmlformats.org/drawingml/2006/main">
             <a:pPr algn="l">
+              <a:buNone/>
               <a:defRPr sz="1350" b="0">
                 <a:solidFill>
                   <a:srgbClr val="555555"/>
@@ -8552,7 +8738,7 @@
       </p:sp>
       <p:cxnSp>
         <p:nvCxnSpPr>
-          <p:cNvPr id="33" name="rule"/>
+          <p:cNvPr id="75" name="rule"/>
           <p:cNvCxnSpPr/>
           <p:nvPr/>
         </p:nvCxnSpPr>
@@ -8636,6 +8822,7 @@
           <a:lstStyle xmlns:a="http://schemas.openxmlformats.org/drawingml/2006/main"/>
           <a:p xmlns:a="http://schemas.openxmlformats.org/drawingml/2006/main">
             <a:pPr algn="l">
+              <a:buNone/>
               <a:defRPr sz="2250" b="1">
                 <a:solidFill>
                   <a:srgbClr val="FF6B35"/>
@@ -8686,6 +8873,7 @@
           <a:lstStyle xmlns:a="http://schemas.openxmlformats.org/drawingml/2006/main"/>
           <a:p xmlns:a="http://schemas.openxmlformats.org/drawingml/2006/main">
             <a:pPr algn="l">
+              <a:buNone/>
               <a:defRPr sz="1350" b="0">
                 <a:solidFill>
                   <a:srgbClr val="555555"/>
@@ -8698,14 +8886,14 @@
                   <a:srgbClr val="555555"/>
                 </a:solidFill>
               </a:rPr>
-              <a:t>DGAT or precomputed output</a:t>
+              <a:t>precomputed DGAT output</a:t>
             </a:r>
           </a:p>
         </p:txBody>
       </p:sp>
       <p:cxnSp>
         <p:nvCxnSpPr>
-          <p:cNvPr id="37" name="rule"/>
+          <p:cNvPr id="79" name="rule"/>
           <p:cNvCxnSpPr/>
           <p:nvPr/>
         </p:nvCxnSpPr>
@@ -8789,6 +8977,7 @@
           <a:lstStyle xmlns:a="http://schemas.openxmlformats.org/drawingml/2006/main"/>
           <a:p xmlns:a="http://schemas.openxmlformats.org/drawingml/2006/main">
             <a:pPr algn="l">
+              <a:buNone/>
               <a:defRPr sz="2250" b="1">
                 <a:solidFill>
                   <a:srgbClr val="000000"/>
@@ -8839,6 +9028,7 @@
           <a:lstStyle xmlns:a="http://schemas.openxmlformats.org/drawingml/2006/main"/>
           <a:p xmlns:a="http://schemas.openxmlformats.org/drawingml/2006/main">
             <a:pPr algn="l">
+              <a:buNone/>
               <a:defRPr sz="1350" b="0">
                 <a:solidFill>
                   <a:srgbClr val="555555"/>
@@ -8889,6 +9079,7 @@
           <a:lstStyle xmlns:a="http://schemas.openxmlformats.org/drawingml/2006/main"/>
           <a:p xmlns:a="http://schemas.openxmlformats.org/drawingml/2006/main">
             <a:pPr algn="l">
+              <a:buNone/>
               <a:defRPr sz="2100" b="1">
                 <a:solidFill>
                   <a:srgbClr val="000000"/>
@@ -8939,6 +9130,7 @@
           <a:lstStyle xmlns:a="http://schemas.openxmlformats.org/drawingml/2006/main"/>
           <a:p xmlns:a="http://schemas.openxmlformats.org/drawingml/2006/main">
             <a:pPr algn="l">
+              <a:buNone/>
               <a:defRPr sz="1950" b="0">
                 <a:solidFill>
                   <a:srgbClr val="555555"/>
@@ -8951,14 +9143,14 @@
                   <a:srgbClr val="555555"/>
                 </a:solidFill>
               </a:rPr>
-              <a:t>Demonstrate one official DGAT prediction run, then continue from data/raw/dgat_predictions.csv for reliability.</a:t>
+              <a:t>Default: load official DGAT output. The optional ridge baseline is out-of-fold, clearly labeled, and not DGAT.</a:t>
             </a:r>
           </a:p>
         </p:txBody>
       </p:sp>
       <p:cxnSp>
         <p:nvCxnSpPr>
-          <p:cNvPr id="43" name="rule"/>
+          <p:cNvPr id="85" name="rule"/>
           <p:cNvCxnSpPr/>
           <p:nvPr/>
         </p:nvCxnSpPr>
@@ -9011,6 +9203,7 @@
           <a:lstStyle xmlns:a="http://schemas.openxmlformats.org/drawingml/2006/main"/>
           <a:p xmlns:a="http://schemas.openxmlformats.org/drawingml/2006/main">
             <a:pPr algn="l">
+              <a:buNone/>
               <a:defRPr sz="1050" b="0">
                 <a:solidFill>
                   <a:srgbClr val="555555"/>
@@ -9059,7 +9252,7 @@
       </p:grpSpPr>
       <p:sp>
         <p:nvSpPr>
-          <p:cNvPr id="1" name="text">
+          <p:cNvPr id="25" name="text">
             <a:extLst xmlns:a="http://schemas.openxmlformats.org/drawingml/2006/main">
               <a:ext uri="{FF2B5EF4-FFF2-40B4-BE49-F238E27FC236}">
                 <a16:creationId xmlns:a16="http://schemas.microsoft.com/office/drawing/2014/main" id="{F9A485A1-EB43-4710-9E9A-74127CD8E05F}"/>
@@ -9090,6 +9283,7 @@
           <a:lstStyle xmlns:a="http://schemas.openxmlformats.org/drawingml/2006/main"/>
           <a:p xmlns:a="http://schemas.openxmlformats.org/drawingml/2006/main">
             <a:pPr algn="l">
+              <a:buNone/>
               <a:defRPr sz="1200" b="1">
                 <a:solidFill>
                   <a:srgbClr val="555555"/>
@@ -9140,6 +9334,7 @@
           <a:lstStyle xmlns:a="http://schemas.openxmlformats.org/drawingml/2006/main"/>
           <a:p xmlns:a="http://schemas.openxmlformats.org/drawingml/2006/main">
             <a:pPr algn="l">
+              <a:buNone/>
               <a:defRPr sz="3150" b="0">
                 <a:solidFill>
                   <a:srgbClr val="000000"/>
@@ -9190,6 +9385,7 @@
           <a:lstStyle xmlns:a="http://schemas.openxmlformats.org/drawingml/2006/main"/>
           <a:p xmlns:a="http://schemas.openxmlformats.org/drawingml/2006/main">
             <a:pPr algn="r">
+              <a:buNone/>
               <a:defRPr sz="1200" b="0">
                 <a:solidFill>
                   <a:srgbClr val="555555"/>
@@ -9209,7 +9405,7 @@
       </p:sp>
       <p:graphicFrame>
         <p:nvGraphicFramePr>
-          <p:cNvPr id="16" name="Chart"/>
+          <p:cNvPr id="40" name="Chart"/>
           <p:cNvGraphicFramePr/>
           <p:nvPr/>
         </p:nvGraphicFramePr>
@@ -9219,7 +9415,7 @@
         </p:xfrm>
         <a:graphic xmlns:a="http://schemas.openxmlformats.org/drawingml/2006/main">
           <a:graphicData uri="http://schemas.openxmlformats.org/drawingml/2006/chart">
-            <c:chart xmlns:r="http://schemas.openxmlformats.org/officeDocument/2006/relationships" xmlns:c="http://schemas.openxmlformats.org/drawingml/2006/chart" r:id="R924277238d564318"/>
+            <c:chart xmlns:r="http://schemas.openxmlformats.org/officeDocument/2006/relationships" xmlns:c="http://schemas.openxmlformats.org/drawingml/2006/chart" r:id="Rbb8e0f70fb614150"/>
           </a:graphicData>
         </a:graphic>
       </p:graphicFrame>
@@ -9256,6 +9452,7 @@
           <a:lstStyle xmlns:a="http://schemas.openxmlformats.org/drawingml/2006/main"/>
           <a:p xmlns:a="http://schemas.openxmlformats.org/drawingml/2006/main">
             <a:pPr algn="l">
+              <a:buNone/>
               <a:defRPr sz="2100" b="1">
                 <a:solidFill>
                   <a:srgbClr val="000000"/>
@@ -9306,6 +9503,7 @@
           <a:lstStyle xmlns:a="http://schemas.openxmlformats.org/drawingml/2006/main"/>
           <a:p xmlns:a="http://schemas.openxmlformats.org/drawingml/2006/main">
             <a:pPr algn="l">
+              <a:buNone/>
               <a:defRPr sz="1650" b="0">
                 <a:solidFill>
                   <a:srgbClr val="555555"/>
@@ -9318,7 +9516,7 @@
                   <a:srgbClr val="555555"/>
                 </a:solidFill>
               </a:rPr>
-              <a:t>Pointwise agreement between observed and inferred proteins.</a:t>
+              <a:t>Pointwise agreement—valid only when evaluation rows were not used to fit their predictions.</a:t>
             </a:r>
           </a:p>
         </p:txBody>
@@ -9387,6 +9585,7 @@
           <a:lstStyle xmlns:a="http://schemas.openxmlformats.org/drawingml/2006/main"/>
           <a:p xmlns:a="http://schemas.openxmlformats.org/drawingml/2006/main">
             <a:pPr algn="l">
+              <a:buNone/>
               <a:defRPr sz="2550" b="1">
                 <a:solidFill>
                   <a:srgbClr val="000000"/>
@@ -9437,6 +9636,7 @@
           <a:lstStyle xmlns:a="http://schemas.openxmlformats.org/drawingml/2006/main"/>
           <a:p xmlns:a="http://schemas.openxmlformats.org/drawingml/2006/main">
             <a:pPr algn="l">
+              <a:buNone/>
               <a:defRPr sz="1800" b="0">
                 <a:solidFill>
                   <a:srgbClr val="555555"/>
@@ -9456,7 +9656,7 @@
       </p:sp>
       <p:cxnSp>
         <p:nvCxnSpPr>
-          <p:cNvPr id="22" name="rule"/>
+          <p:cNvPr id="46" name="rule"/>
           <p:cNvCxnSpPr/>
           <p:nvPr/>
         </p:nvCxnSpPr>
@@ -9478,7 +9678,7 @@
       </p:cxnSp>
       <p:cxnSp>
         <p:nvCxnSpPr>
-          <p:cNvPr id="23" name="rule"/>
+          <p:cNvPr id="47" name="rule"/>
           <p:cNvCxnSpPr/>
           <p:nvPr/>
         </p:nvCxnSpPr>
@@ -9531,6 +9731,7 @@
           <a:lstStyle xmlns:a="http://schemas.openxmlformats.org/drawingml/2006/main"/>
           <a:p xmlns:a="http://schemas.openxmlformats.org/drawingml/2006/main">
             <a:pPr algn="l">
+              <a:buNone/>
               <a:defRPr sz="1050" b="0">
                 <a:solidFill>
                   <a:srgbClr val="555555"/>
@@ -9579,7 +9780,7 @@
       </p:grpSpPr>
       <p:sp>
         <p:nvSpPr>
-          <p:cNvPr id="1" name="text">
+          <p:cNvPr id="34" name="text">
             <a:extLst xmlns:a="http://schemas.openxmlformats.org/drawingml/2006/main">
               <a:ext uri="{FF2B5EF4-FFF2-40B4-BE49-F238E27FC236}">
                 <a16:creationId xmlns:a16="http://schemas.microsoft.com/office/drawing/2014/main" id="{0EA18D50-6C33-486B-BAD4-45EC986D2711}"/>
@@ -9610,6 +9811,7 @@
           <a:lstStyle xmlns:a="http://schemas.openxmlformats.org/drawingml/2006/main"/>
           <a:p xmlns:a="http://schemas.openxmlformats.org/drawingml/2006/main">
             <a:pPr algn="l">
+              <a:buNone/>
               <a:defRPr sz="1200" b="1">
                 <a:solidFill>
                   <a:srgbClr val="555555"/>
@@ -9660,6 +9862,7 @@
           <a:lstStyle xmlns:a="http://schemas.openxmlformats.org/drawingml/2006/main"/>
           <a:p xmlns:a="http://schemas.openxmlformats.org/drawingml/2006/main">
             <a:pPr algn="l">
+              <a:buNone/>
               <a:defRPr sz="3150" b="0">
                 <a:solidFill>
                   <a:srgbClr val="000000"/>
@@ -9710,6 +9913,7 @@
           <a:lstStyle xmlns:a="http://schemas.openxmlformats.org/drawingml/2006/main"/>
           <a:p xmlns:a="http://schemas.openxmlformats.org/drawingml/2006/main">
             <a:pPr algn="r">
+              <a:buNone/>
               <a:defRPr sz="1200" b="0">
                 <a:solidFill>
                   <a:srgbClr val="555555"/>
@@ -9791,6 +9995,7 @@
           <a:lstStyle xmlns:a="http://schemas.openxmlformats.org/drawingml/2006/main"/>
           <a:p xmlns:a="http://schemas.openxmlformats.org/drawingml/2006/main">
             <a:pPr algn="l">
+              <a:buNone/>
               <a:defRPr sz="2025" b="1">
                 <a:solidFill>
                   <a:srgbClr val="000000"/>
@@ -9841,6 +10046,7 @@
           <a:lstStyle xmlns:a="http://schemas.openxmlformats.org/drawingml/2006/main"/>
           <a:p xmlns:a="http://schemas.openxmlformats.org/drawingml/2006/main">
             <a:pPr algn="l">
+              <a:buNone/>
               <a:defRPr sz="1500" b="0">
                 <a:solidFill>
                   <a:srgbClr val="555555"/>
@@ -9922,6 +10128,7 @@
           <a:lstStyle xmlns:a="http://schemas.openxmlformats.org/drawingml/2006/main"/>
           <a:p xmlns:a="http://schemas.openxmlformats.org/drawingml/2006/main">
             <a:pPr algn="l">
+              <a:buNone/>
               <a:defRPr sz="2025" b="1">
                 <a:solidFill>
                   <a:srgbClr val="000000"/>
@@ -9972,6 +10179,7 @@
           <a:lstStyle xmlns:a="http://schemas.openxmlformats.org/drawingml/2006/main"/>
           <a:p xmlns:a="http://schemas.openxmlformats.org/drawingml/2006/main">
             <a:pPr algn="l">
+              <a:buNone/>
               <a:defRPr sz="1500" b="0">
                 <a:solidFill>
                   <a:srgbClr val="555555"/>
@@ -10053,6 +10261,7 @@
           <a:lstStyle xmlns:a="http://schemas.openxmlformats.org/drawingml/2006/main"/>
           <a:p xmlns:a="http://schemas.openxmlformats.org/drawingml/2006/main">
             <a:pPr algn="l">
+              <a:buNone/>
               <a:defRPr sz="2025" b="1">
                 <a:solidFill>
                   <a:srgbClr val="000000"/>
@@ -10103,6 +10312,7 @@
           <a:lstStyle xmlns:a="http://schemas.openxmlformats.org/drawingml/2006/main"/>
           <a:p xmlns:a="http://schemas.openxmlformats.org/drawingml/2006/main">
             <a:pPr algn="l">
+              <a:buNone/>
               <a:defRPr sz="1500" b="0">
                 <a:solidFill>
                   <a:srgbClr val="555555"/>
@@ -10184,6 +10394,7 @@
           <a:lstStyle xmlns:a="http://schemas.openxmlformats.org/drawingml/2006/main"/>
           <a:p xmlns:a="http://schemas.openxmlformats.org/drawingml/2006/main">
             <a:pPr algn="l">
+              <a:buNone/>
               <a:defRPr sz="2025" b="1">
                 <a:solidFill>
                   <a:srgbClr val="000000"/>
@@ -10234,6 +10445,7 @@
           <a:lstStyle xmlns:a="http://schemas.openxmlformats.org/drawingml/2006/main"/>
           <a:p xmlns:a="http://schemas.openxmlformats.org/drawingml/2006/main">
             <a:pPr algn="l">
+              <a:buNone/>
               <a:defRPr sz="1500" b="0">
                 <a:solidFill>
                   <a:srgbClr val="555555"/>
@@ -10253,7 +10465,7 @@
       </p:sp>
       <p:cxnSp>
         <p:nvCxnSpPr>
-          <p:cNvPr id="33" name="rule"/>
+          <p:cNvPr id="65" name="rule"/>
           <p:cNvCxnSpPr/>
           <p:nvPr/>
         </p:nvCxnSpPr>
@@ -10306,6 +10518,7 @@
           <a:lstStyle xmlns:a="http://schemas.openxmlformats.org/drawingml/2006/main"/>
           <a:p xmlns:a="http://schemas.openxmlformats.org/drawingml/2006/main">
             <a:pPr algn="l">
+              <a:buNone/>
               <a:defRPr sz="1050" b="0">
                 <a:solidFill>
                   <a:srgbClr val="555555"/>

</xml_diff>